<commit_message>
Align slide 10 priorities and FMEA IDs with the Excel worksheet
- Root cause '조치 추적 체계 부재' raised to 높음 (9.2.15 RPN 392)
- Add missing linked IDs 5.2.2, 9.1.1, 9.1.14, 9.2.11
- Footnote states priority basis and that IDs are the Excel ID column
- Slide 4 labels 9.1.8 / 9.2.7 marked as step numbers

Co-Authored-By: Claude Opus 5.5 (1M context) <noreply@anthropic.com>
Claude-Session: https://claude.ai/code/session_01WUjepw1sz5aFPZoKZTRwKV
</commit_message>
<xml_diff>
--- a/CPR_프로세스_원인분석.pptx
+++ b/CPR_프로세스_원인분석.pptx
@@ -2815,7 +2815,7 @@
                             <a:schemeClr val="tx1"/>
                           </a:solidFill>
                         </a:rPr>
-                        <a:t>9.3.1 · 9.3.2 · 7.2.1</a:t>
+                        <a:t>9.3.1 · 9.3.2 · 7.2.1 · 5.2.2</a:t>
                       </a:r>
                       <a:endParaRPr lang="en-US" sz="1200" dirty="0"/>
                     </a:p>
@@ -3429,7 +3429,7 @@
                             <a:schemeClr val="tx1"/>
                           </a:solidFill>
                         </a:rPr>
-                        <a:t>9.1.5 · 9.1.10 · 9.1.16</a:t>
+                        <a:t>9.1.1 · 9.1.5 · 9.1.10 · 9.1.14 · 9.1.16</a:t>
                       </a:r>
                       <a:endParaRPr lang="en-US" sz="1200" dirty="0"/>
                     </a:p>
@@ -3736,7 +3736,7 @@
                             <a:schemeClr val="tx1"/>
                           </a:solidFill>
                         </a:rPr>
-                        <a:t>9.2.5 ~ 9.2.7 · 3.1.1</a:t>
+                        <a:t>9.2.5 ~ 9.2.7 · 9.2.11 · 3.1.1</a:t>
                       </a:r>
                       <a:endParaRPr lang="en-US" sz="1200" dirty="0"/>
                     </a:p>
@@ -3918,10 +3918,10 @@
                       <a:r>
                         <a:rPr lang="en-US" sz="1200" b="1" dirty="0">
                           <a:solidFill>
-                            <a:schemeClr val="accent3"/>
+                            <a:schemeClr val="accent2"/>
                           </a:solidFill>
                         </a:rPr>
-                        <a:t>중간</a:t>
+                        <a:t>높음</a:t>
                       </a:r>
                       <a:endParaRPr lang="en-US" sz="1200" dirty="0"/>
                     </a:p>
@@ -4186,7 +4186,7 @@
                   <a:schemeClr val="accent3"/>
                 </a:solidFill>
               </a:rPr>
-              <a:t>우선순위와 연결 ID는 CPR_FMEA_워크시트.xlsx의 행과 같습니다. 점수는 초안이므로 팀 합의로 재평가하세요.</a:t>
+              <a:t>우선순위는 연결 ID 중 가장 높은 등급을 따르며, 연결 ID는 CPR_FMEA_워크시트.xlsx의 ID 열입니다. 점수는 초안이므로 팀 합의로 재평가하세요.</a:t>
             </a:r>
             <a:endParaRPr lang="en-US" sz="1100" dirty="0"/>
           </a:p>
@@ -7325,7 +7325,7 @@
                   <a:schemeClr val="bg1"/>
                 </a:solidFill>
               </a:rPr>
-              <a:t>9.1.8</a:t>
+              <a:t>단계 9.1.8</a:t>
             </a:r>
             <a:endParaRPr lang="en-US" sz="1300" dirty="0"/>
           </a:p>
@@ -7625,7 +7625,7 @@
                   <a:schemeClr val="bg1"/>
                 </a:solidFill>
               </a:rPr>
-              <a:t>9.2.7</a:t>
+              <a:t>단계 9.2.7</a:t>
             </a:r>
             <a:endParaRPr lang="en-US" sz="1300" dirty="0"/>
           </a:p>

</xml_diff>